<commit_message>
Update 2026 WSDS - Wujian Xue.pptx
</commit_message>
<xml_diff>
--- a/2026 WSDS - Wujian Xue.pptx
+++ b/2026 WSDS - Wujian Xue.pptx
@@ -6,6 +6,11 @@
   </p:sldMasterIdLst>
   <p:sldIdLst>
     <p:sldId id="256" r:id="rId2"/>
+    <p:sldId id="257" r:id="rId3"/>
+    <p:sldId id="258" r:id="rId4"/>
+    <p:sldId id="259" r:id="rId5"/>
+    <p:sldId id="260" r:id="rId6"/>
+    <p:sldId id="261" r:id="rId7"/>
   </p:sldIdLst>
   <p:sldSz cx="12192000" cy="6858000"/>
   <p:notesSz cx="6858000" cy="9144000"/>
@@ -104,6 +109,11 @@
       </a:defRPr>
     </a:lvl9pPr>
   </p:defaultTextStyle>
+  <p:extLst>
+    <p:ext uri="{EFAFB233-063F-42B5-8137-9DF3F51BA10A}">
+      <p15:sldGuideLst xmlns:p15="http://schemas.microsoft.com/office/powerpoint/2012/main"/>
+    </p:ext>
+  </p:extLst>
 </p:presentation>
 </file>
 
@@ -254,7 +264,7 @@
           <a:p>
             <a:fld id="{9DFF5FDE-556D-4288-960F-3880543CC0D0}" type="datetimeFigureOut">
               <a:rPr lang="en-US" smtClean="0"/>
-              <a:t>9/27/2026</a:t>
+              <a:t>10/4/2026</a:t>
             </a:fld>
             <a:endParaRPr lang="en-US"/>
           </a:p>
@@ -452,7 +462,7 @@
           <a:p>
             <a:fld id="{9DFF5FDE-556D-4288-960F-3880543CC0D0}" type="datetimeFigureOut">
               <a:rPr lang="en-US" smtClean="0"/>
-              <a:t>9/27/2026</a:t>
+              <a:t>10/4/2026</a:t>
             </a:fld>
             <a:endParaRPr lang="en-US"/>
           </a:p>
@@ -660,7 +670,7 @@
           <a:p>
             <a:fld id="{9DFF5FDE-556D-4288-960F-3880543CC0D0}" type="datetimeFigureOut">
               <a:rPr lang="en-US" smtClean="0"/>
-              <a:t>9/27/2026</a:t>
+              <a:t>10/4/2026</a:t>
             </a:fld>
             <a:endParaRPr lang="en-US"/>
           </a:p>
@@ -858,7 +868,7 @@
           <a:p>
             <a:fld id="{9DFF5FDE-556D-4288-960F-3880543CC0D0}" type="datetimeFigureOut">
               <a:rPr lang="en-US" smtClean="0"/>
-              <a:t>9/27/2026</a:t>
+              <a:t>10/4/2026</a:t>
             </a:fld>
             <a:endParaRPr lang="en-US"/>
           </a:p>
@@ -1133,7 +1143,7 @@
           <a:p>
             <a:fld id="{9DFF5FDE-556D-4288-960F-3880543CC0D0}" type="datetimeFigureOut">
               <a:rPr lang="en-US" smtClean="0"/>
-              <a:t>9/27/2026</a:t>
+              <a:t>10/4/2026</a:t>
             </a:fld>
             <a:endParaRPr lang="en-US"/>
           </a:p>
@@ -1398,7 +1408,7 @@
           <a:p>
             <a:fld id="{9DFF5FDE-556D-4288-960F-3880543CC0D0}" type="datetimeFigureOut">
               <a:rPr lang="en-US" smtClean="0"/>
-              <a:t>9/27/2026</a:t>
+              <a:t>10/4/2026</a:t>
             </a:fld>
             <a:endParaRPr lang="en-US"/>
           </a:p>
@@ -1810,7 +1820,7 @@
           <a:p>
             <a:fld id="{9DFF5FDE-556D-4288-960F-3880543CC0D0}" type="datetimeFigureOut">
               <a:rPr lang="en-US" smtClean="0"/>
-              <a:t>9/27/2026</a:t>
+              <a:t>10/4/2026</a:t>
             </a:fld>
             <a:endParaRPr lang="en-US"/>
           </a:p>
@@ -1951,7 +1961,7 @@
           <a:p>
             <a:fld id="{9DFF5FDE-556D-4288-960F-3880543CC0D0}" type="datetimeFigureOut">
               <a:rPr lang="en-US" smtClean="0"/>
-              <a:t>9/27/2026</a:t>
+              <a:t>10/4/2026</a:t>
             </a:fld>
             <a:endParaRPr lang="en-US"/>
           </a:p>
@@ -2064,7 +2074,7 @@
           <a:p>
             <a:fld id="{9DFF5FDE-556D-4288-960F-3880543CC0D0}" type="datetimeFigureOut">
               <a:rPr lang="en-US" smtClean="0"/>
-              <a:t>9/27/2026</a:t>
+              <a:t>10/4/2026</a:t>
             </a:fld>
             <a:endParaRPr lang="en-US"/>
           </a:p>
@@ -2375,7 +2385,7 @@
           <a:p>
             <a:fld id="{9DFF5FDE-556D-4288-960F-3880543CC0D0}" type="datetimeFigureOut">
               <a:rPr lang="en-US" smtClean="0"/>
-              <a:t>9/27/2026</a:t>
+              <a:t>10/4/2026</a:t>
             </a:fld>
             <a:endParaRPr lang="en-US"/>
           </a:p>
@@ -2663,7 +2673,7 @@
           <a:p>
             <a:fld id="{9DFF5FDE-556D-4288-960F-3880543CC0D0}" type="datetimeFigureOut">
               <a:rPr lang="en-US" smtClean="0"/>
-              <a:t>9/27/2026</a:t>
+              <a:t>10/4/2026</a:t>
             </a:fld>
             <a:endParaRPr lang="en-US"/>
           </a:p>
@@ -2904,7 +2914,7 @@
           <a:p>
             <a:fld id="{9DFF5FDE-556D-4288-960F-3880543CC0D0}" type="datetimeFigureOut">
               <a:rPr lang="en-US" smtClean="0"/>
-              <a:t>9/27/2026</a:t>
+              <a:t>10/4/2026</a:t>
             </a:fld>
             <a:endParaRPr lang="en-US"/>
           </a:p>
@@ -3339,8 +3349,8 @@
         </p:nvSpPr>
         <p:spPr>
           <a:xfrm>
-            <a:off x="487017" y="1122363"/>
-            <a:ext cx="11569148" cy="2387600"/>
+            <a:off x="67917" y="311771"/>
+            <a:ext cx="12056165" cy="2387600"/>
           </a:xfrm>
         </p:spPr>
         <p:txBody>
@@ -3350,10 +3360,35 @@
           <a:lstStyle/>
           <a:p>
             <a:r>
-              <a:rPr lang="en-US" b="1" dirty="0"/>
-              <a:t>From On-Premise to Cloud: Lessons Learned from an Enterprise AWS Migration at Fannie Mae</a:t>
-            </a:r>
-            <a:endParaRPr lang="en-US" dirty="0"/>
+              <a:rPr lang="en-US" sz="8000" b="1" dirty="0">
+                <a:latin typeface="Times New Roman" panose="02020603050405020304" pitchFamily="18" charset="0"/>
+                <a:cs typeface="Times New Roman" panose="02020603050405020304" pitchFamily="18" charset="0"/>
+              </a:rPr>
+              <a:t>From On-Premise to Cloud: </a:t>
+            </a:r>
+            <a:br>
+              <a:rPr lang="en-US" b="1" dirty="0">
+                <a:latin typeface="Times New Roman" panose="02020603050405020304" pitchFamily="18" charset="0"/>
+                <a:cs typeface="Times New Roman" panose="02020603050405020304" pitchFamily="18" charset="0"/>
+              </a:rPr>
+            </a:br>
+            <a:br>
+              <a:rPr lang="en-US" sz="3200" b="1" dirty="0">
+                <a:latin typeface="Times New Roman" panose="02020603050405020304" pitchFamily="18" charset="0"/>
+                <a:cs typeface="Times New Roman" panose="02020603050405020304" pitchFamily="18" charset="0"/>
+              </a:rPr>
+            </a:br>
+            <a:r>
+              <a:rPr lang="en-US" sz="3200" b="1" dirty="0">
+                <a:latin typeface="Times New Roman" panose="02020603050405020304" pitchFamily="18" charset="0"/>
+                <a:cs typeface="Times New Roman" panose="02020603050405020304" pitchFamily="18" charset="0"/>
+              </a:rPr>
+              <a:t>Lessons Learned from an Enterprise AWS Migration at Fannie Mae</a:t>
+            </a:r>
+            <a:endParaRPr lang="en-US" sz="3200" dirty="0">
+              <a:latin typeface="Times New Roman" panose="02020603050405020304" pitchFamily="18" charset="0"/>
+              <a:cs typeface="Times New Roman" panose="02020603050405020304" pitchFamily="18" charset="0"/>
+            </a:endParaRPr>
           </a:p>
         </p:txBody>
       </p:sp>
@@ -3373,19 +3408,30 @@
             <p:ph type="subTitle" idx="1"/>
           </p:nvPr>
         </p:nvSpPr>
-        <p:spPr/>
-        <p:txBody>
-          <a:bodyPr/>
-          <a:lstStyle/>
-          <a:p>
-            <a:r>
-              <a:rPr lang="en-US" altLang="zh-CN" dirty="0"/>
+        <p:spPr>
+          <a:xfrm>
+            <a:off x="1524000" y="4158629"/>
+            <a:ext cx="9144000" cy="1655762"/>
+          </a:xfrm>
+        </p:spPr>
+        <p:txBody>
+          <a:bodyPr/>
+          <a:lstStyle/>
+          <a:p>
+            <a:r>
+              <a:rPr lang="en-US" altLang="zh-CN" dirty="0">
+                <a:latin typeface="Times New Roman" panose="02020603050405020304" pitchFamily="18" charset="0"/>
+                <a:cs typeface="Times New Roman" panose="02020603050405020304" pitchFamily="18" charset="0"/>
+              </a:rPr>
               <a:t>Wujian Xue</a:t>
             </a:r>
           </a:p>
           <a:p>
             <a:r>
-              <a:rPr lang="en-US"/>
+              <a:rPr lang="en-US" dirty="0">
+                <a:latin typeface="Times New Roman" panose="02020603050405020304" pitchFamily="18" charset="0"/>
+                <a:cs typeface="Times New Roman" panose="02020603050405020304" pitchFamily="18" charset="0"/>
+              </a:rPr>
               <a:t>Oct 2026</a:t>
             </a:r>
           </a:p>
@@ -3395,6 +3441,431 @@
     <p:extLst>
       <p:ext uri="{BB962C8B-B14F-4D97-AF65-F5344CB8AC3E}">
         <p14:creationId xmlns:p14="http://schemas.microsoft.com/office/powerpoint/2010/main" val="2572152849"/>
+      </p:ext>
+    </p:extLst>
+  </p:cSld>
+  <p:clrMapOvr>
+    <a:masterClrMapping/>
+  </p:clrMapOvr>
+</p:sld>
+</file>
+
+<file path=ppt/slides/slide2.xml><?xml version="1.0" encoding="utf-8"?>
+<p:sld xmlns:a="http://schemas.openxmlformats.org/drawingml/2006/main" xmlns:r="http://schemas.openxmlformats.org/officeDocument/2006/relationships" xmlns:p="http://schemas.openxmlformats.org/presentationml/2006/main">
+  <p:cSld>
+    <p:spTree>
+      <p:nvGrpSpPr>
+        <p:cNvPr id="1" name=""/>
+        <p:cNvGrpSpPr/>
+        <p:nvPr/>
+      </p:nvGrpSpPr>
+      <p:grpSpPr>
+        <a:xfrm>
+          <a:off x="0" y="0"/>
+          <a:ext cx="0" cy="0"/>
+          <a:chOff x="0" y="0"/>
+          <a:chExt cx="0" cy="0"/>
+        </a:xfrm>
+      </p:grpSpPr>
+      <p:sp>
+        <p:nvSpPr>
+          <p:cNvPr id="2" name="Title 1">
+            <a:extLst>
+              <a:ext uri="{FF2B5EF4-FFF2-40B4-BE49-F238E27FC236}">
+                <a16:creationId xmlns:a16="http://schemas.microsoft.com/office/drawing/2014/main" id="{77E4F433-6378-4049-F2C3-EE92E0049A7B}"/>
+              </a:ext>
+            </a:extLst>
+          </p:cNvPr>
+          <p:cNvSpPr>
+            <a:spLocks noGrp="1"/>
+          </p:cNvSpPr>
+          <p:nvPr>
+            <p:ph type="title"/>
+          </p:nvPr>
+        </p:nvSpPr>
+        <p:spPr/>
+        <p:txBody>
+          <a:bodyPr/>
+          <a:lstStyle/>
+          <a:p>
+            <a:r>
+              <a:rPr lang="en-US" dirty="0"/>
+              <a:t>Background</a:t>
+            </a:r>
+          </a:p>
+        </p:txBody>
+      </p:sp>
+      <p:sp>
+        <p:nvSpPr>
+          <p:cNvPr id="3" name="Content Placeholder 2">
+            <a:extLst>
+              <a:ext uri="{FF2B5EF4-FFF2-40B4-BE49-F238E27FC236}">
+                <a16:creationId xmlns:a16="http://schemas.microsoft.com/office/drawing/2014/main" id="{FF3838B1-29DE-A684-2D91-585BAAF4FB7E}"/>
+              </a:ext>
+            </a:extLst>
+          </p:cNvPr>
+          <p:cNvSpPr>
+            <a:spLocks noGrp="1"/>
+          </p:cNvSpPr>
+          <p:nvPr>
+            <p:ph idx="1"/>
+          </p:nvPr>
+        </p:nvSpPr>
+        <p:spPr/>
+        <p:txBody>
+          <a:bodyPr/>
+          <a:lstStyle/>
+          <a:p>
+            <a:r>
+              <a:rPr lang="en-US" dirty="0"/>
+              <a:t>What is the problem and why</a:t>
+            </a:r>
+          </a:p>
+        </p:txBody>
+      </p:sp>
+    </p:spTree>
+    <p:extLst>
+      <p:ext uri="{BB962C8B-B14F-4D97-AF65-F5344CB8AC3E}">
+        <p14:creationId xmlns:p14="http://schemas.microsoft.com/office/powerpoint/2010/main" val="2985780587"/>
+      </p:ext>
+    </p:extLst>
+  </p:cSld>
+  <p:clrMapOvr>
+    <a:masterClrMapping/>
+  </p:clrMapOvr>
+</p:sld>
+</file>
+
+<file path=ppt/slides/slide3.xml><?xml version="1.0" encoding="utf-8"?>
+<p:sld xmlns:a="http://schemas.openxmlformats.org/drawingml/2006/main" xmlns:r="http://schemas.openxmlformats.org/officeDocument/2006/relationships" xmlns:p="http://schemas.openxmlformats.org/presentationml/2006/main">
+  <p:cSld>
+    <p:spTree>
+      <p:nvGrpSpPr>
+        <p:cNvPr id="1" name=""/>
+        <p:cNvGrpSpPr/>
+        <p:nvPr/>
+      </p:nvGrpSpPr>
+      <p:grpSpPr>
+        <a:xfrm>
+          <a:off x="0" y="0"/>
+          <a:ext cx="0" cy="0"/>
+          <a:chOff x="0" y="0"/>
+          <a:chExt cx="0" cy="0"/>
+        </a:xfrm>
+      </p:grpSpPr>
+      <p:sp>
+        <p:nvSpPr>
+          <p:cNvPr id="2" name="Title 1">
+            <a:extLst>
+              <a:ext uri="{FF2B5EF4-FFF2-40B4-BE49-F238E27FC236}">
+                <a16:creationId xmlns:a16="http://schemas.microsoft.com/office/drawing/2014/main" id="{BA84EECB-BE89-FA10-B559-C2D06E9BFD18}"/>
+              </a:ext>
+            </a:extLst>
+          </p:cNvPr>
+          <p:cNvSpPr>
+            <a:spLocks noGrp="1"/>
+          </p:cNvSpPr>
+          <p:nvPr>
+            <p:ph type="title"/>
+          </p:nvPr>
+        </p:nvSpPr>
+        <p:spPr/>
+        <p:txBody>
+          <a:bodyPr/>
+          <a:lstStyle/>
+          <a:p>
+            <a:endParaRPr lang="en-US"/>
+          </a:p>
+        </p:txBody>
+      </p:sp>
+      <p:sp>
+        <p:nvSpPr>
+          <p:cNvPr id="3" name="Content Placeholder 2">
+            <a:extLst>
+              <a:ext uri="{FF2B5EF4-FFF2-40B4-BE49-F238E27FC236}">
+                <a16:creationId xmlns:a16="http://schemas.microsoft.com/office/drawing/2014/main" id="{D79C73C9-79BC-BE4B-D99B-67D620D66A20}"/>
+              </a:ext>
+            </a:extLst>
+          </p:cNvPr>
+          <p:cNvSpPr>
+            <a:spLocks noGrp="1"/>
+          </p:cNvSpPr>
+          <p:nvPr>
+            <p:ph idx="1"/>
+          </p:nvPr>
+        </p:nvSpPr>
+        <p:spPr/>
+        <p:txBody>
+          <a:bodyPr/>
+          <a:lstStyle/>
+          <a:p>
+            <a:r>
+              <a:rPr lang="en-US" dirty="0"/>
+              <a:t>What has been done about it?</a:t>
+            </a:r>
+          </a:p>
+          <a:p>
+            <a:endParaRPr lang="en-US" dirty="0"/>
+          </a:p>
+        </p:txBody>
+      </p:sp>
+    </p:spTree>
+    <p:extLst>
+      <p:ext uri="{BB962C8B-B14F-4D97-AF65-F5344CB8AC3E}">
+        <p14:creationId xmlns:p14="http://schemas.microsoft.com/office/powerpoint/2010/main" val="3421866799"/>
+      </p:ext>
+    </p:extLst>
+  </p:cSld>
+  <p:clrMapOvr>
+    <a:masterClrMapping/>
+  </p:clrMapOvr>
+</p:sld>
+</file>
+
+<file path=ppt/slides/slide4.xml><?xml version="1.0" encoding="utf-8"?>
+<p:sld xmlns:a="http://schemas.openxmlformats.org/drawingml/2006/main" xmlns:r="http://schemas.openxmlformats.org/officeDocument/2006/relationships" xmlns:p="http://schemas.openxmlformats.org/presentationml/2006/main">
+  <p:cSld>
+    <p:spTree>
+      <p:nvGrpSpPr>
+        <p:cNvPr id="1" name=""/>
+        <p:cNvGrpSpPr/>
+        <p:nvPr/>
+      </p:nvGrpSpPr>
+      <p:grpSpPr>
+        <a:xfrm>
+          <a:off x="0" y="0"/>
+          <a:ext cx="0" cy="0"/>
+          <a:chOff x="0" y="0"/>
+          <a:chExt cx="0" cy="0"/>
+        </a:xfrm>
+      </p:grpSpPr>
+      <p:sp>
+        <p:nvSpPr>
+          <p:cNvPr id="2" name="Title 1">
+            <a:extLst>
+              <a:ext uri="{FF2B5EF4-FFF2-40B4-BE49-F238E27FC236}">
+                <a16:creationId xmlns:a16="http://schemas.microsoft.com/office/drawing/2014/main" id="{8DB06789-BA5D-116A-9606-AAEF943A72D0}"/>
+              </a:ext>
+            </a:extLst>
+          </p:cNvPr>
+          <p:cNvSpPr>
+            <a:spLocks noGrp="1"/>
+          </p:cNvSpPr>
+          <p:nvPr>
+            <p:ph type="title"/>
+          </p:nvPr>
+        </p:nvSpPr>
+        <p:spPr/>
+        <p:txBody>
+          <a:bodyPr/>
+          <a:lstStyle/>
+          <a:p>
+            <a:endParaRPr lang="en-US"/>
+          </a:p>
+        </p:txBody>
+      </p:sp>
+      <p:sp>
+        <p:nvSpPr>
+          <p:cNvPr id="3" name="Content Placeholder 2">
+            <a:extLst>
+              <a:ext uri="{FF2B5EF4-FFF2-40B4-BE49-F238E27FC236}">
+                <a16:creationId xmlns:a16="http://schemas.microsoft.com/office/drawing/2014/main" id="{543B8BDC-C4C6-0905-5F9F-38B1383CEAC1}"/>
+              </a:ext>
+            </a:extLst>
+          </p:cNvPr>
+          <p:cNvSpPr>
+            <a:spLocks noGrp="1"/>
+          </p:cNvSpPr>
+          <p:nvPr>
+            <p:ph idx="1"/>
+          </p:nvPr>
+        </p:nvSpPr>
+        <p:spPr/>
+        <p:txBody>
+          <a:bodyPr/>
+          <a:lstStyle/>
+          <a:p>
+            <a:r>
+              <a:rPr lang="en-US" dirty="0"/>
+              <a:t>What have I done about it?</a:t>
+            </a:r>
+          </a:p>
+        </p:txBody>
+      </p:sp>
+    </p:spTree>
+    <p:extLst>
+      <p:ext uri="{BB962C8B-B14F-4D97-AF65-F5344CB8AC3E}">
+        <p14:creationId xmlns:p14="http://schemas.microsoft.com/office/powerpoint/2010/main" val="3588703417"/>
+      </p:ext>
+    </p:extLst>
+  </p:cSld>
+  <p:clrMapOvr>
+    <a:masterClrMapping/>
+  </p:clrMapOvr>
+</p:sld>
+</file>
+
+<file path=ppt/slides/slide5.xml><?xml version="1.0" encoding="utf-8"?>
+<p:sld xmlns:a="http://schemas.openxmlformats.org/drawingml/2006/main" xmlns:r="http://schemas.openxmlformats.org/officeDocument/2006/relationships" xmlns:p="http://schemas.openxmlformats.org/presentationml/2006/main">
+  <p:cSld>
+    <p:spTree>
+      <p:nvGrpSpPr>
+        <p:cNvPr id="1" name=""/>
+        <p:cNvGrpSpPr/>
+        <p:nvPr/>
+      </p:nvGrpSpPr>
+      <p:grpSpPr>
+        <a:xfrm>
+          <a:off x="0" y="0"/>
+          <a:ext cx="0" cy="0"/>
+          <a:chOff x="0" y="0"/>
+          <a:chExt cx="0" cy="0"/>
+        </a:xfrm>
+      </p:grpSpPr>
+      <p:sp>
+        <p:nvSpPr>
+          <p:cNvPr id="2" name="Title 1">
+            <a:extLst>
+              <a:ext uri="{FF2B5EF4-FFF2-40B4-BE49-F238E27FC236}">
+                <a16:creationId xmlns:a16="http://schemas.microsoft.com/office/drawing/2014/main" id="{B43C6558-4EC7-F455-AEE9-D12FD0A89C62}"/>
+              </a:ext>
+            </a:extLst>
+          </p:cNvPr>
+          <p:cNvSpPr>
+            <a:spLocks noGrp="1"/>
+          </p:cNvSpPr>
+          <p:nvPr>
+            <p:ph type="title"/>
+          </p:nvPr>
+        </p:nvSpPr>
+        <p:spPr/>
+        <p:txBody>
+          <a:bodyPr/>
+          <a:lstStyle/>
+          <a:p>
+            <a:endParaRPr lang="en-US"/>
+          </a:p>
+        </p:txBody>
+      </p:sp>
+      <p:sp>
+        <p:nvSpPr>
+          <p:cNvPr id="3" name="Content Placeholder 2">
+            <a:extLst>
+              <a:ext uri="{FF2B5EF4-FFF2-40B4-BE49-F238E27FC236}">
+                <a16:creationId xmlns:a16="http://schemas.microsoft.com/office/drawing/2014/main" id="{5655E68B-3CB9-4EB7-342D-A9E2A3772252}"/>
+              </a:ext>
+            </a:extLst>
+          </p:cNvPr>
+          <p:cNvSpPr>
+            <a:spLocks noGrp="1"/>
+          </p:cNvSpPr>
+          <p:nvPr>
+            <p:ph idx="1"/>
+          </p:nvPr>
+        </p:nvSpPr>
+        <p:spPr/>
+        <p:txBody>
+          <a:bodyPr/>
+          <a:lstStyle/>
+          <a:p>
+            <a:r>
+              <a:rPr lang="en-US" dirty="0"/>
+              <a:t>What additional value does my approach provide?</a:t>
+            </a:r>
+          </a:p>
+        </p:txBody>
+      </p:sp>
+    </p:spTree>
+    <p:extLst>
+      <p:ext uri="{BB962C8B-B14F-4D97-AF65-F5344CB8AC3E}">
+        <p14:creationId xmlns:p14="http://schemas.microsoft.com/office/powerpoint/2010/main" val="331261954"/>
+      </p:ext>
+    </p:extLst>
+  </p:cSld>
+  <p:clrMapOvr>
+    <a:masterClrMapping/>
+  </p:clrMapOvr>
+</p:sld>
+</file>
+
+<file path=ppt/slides/slide6.xml><?xml version="1.0" encoding="utf-8"?>
+<p:sld xmlns:a="http://schemas.openxmlformats.org/drawingml/2006/main" xmlns:r="http://schemas.openxmlformats.org/officeDocument/2006/relationships" xmlns:p="http://schemas.openxmlformats.org/presentationml/2006/main">
+  <p:cSld>
+    <p:spTree>
+      <p:nvGrpSpPr>
+        <p:cNvPr id="1" name=""/>
+        <p:cNvGrpSpPr/>
+        <p:nvPr/>
+      </p:nvGrpSpPr>
+      <p:grpSpPr>
+        <a:xfrm>
+          <a:off x="0" y="0"/>
+          <a:ext cx="0" cy="0"/>
+          <a:chOff x="0" y="0"/>
+          <a:chExt cx="0" cy="0"/>
+        </a:xfrm>
+      </p:grpSpPr>
+      <p:sp>
+        <p:nvSpPr>
+          <p:cNvPr id="2" name="Title 1">
+            <a:extLst>
+              <a:ext uri="{FF2B5EF4-FFF2-40B4-BE49-F238E27FC236}">
+                <a16:creationId xmlns:a16="http://schemas.microsoft.com/office/drawing/2014/main" id="{9E681912-C0D5-AF85-91B0-7D9532929F7F}"/>
+              </a:ext>
+            </a:extLst>
+          </p:cNvPr>
+          <p:cNvSpPr>
+            <a:spLocks noGrp="1"/>
+          </p:cNvSpPr>
+          <p:nvPr>
+            <p:ph type="title"/>
+          </p:nvPr>
+        </p:nvSpPr>
+        <p:spPr/>
+        <p:txBody>
+          <a:bodyPr/>
+          <a:lstStyle/>
+          <a:p>
+            <a:endParaRPr lang="en-US"/>
+          </a:p>
+        </p:txBody>
+      </p:sp>
+      <p:sp>
+        <p:nvSpPr>
+          <p:cNvPr id="3" name="Content Placeholder 2">
+            <a:extLst>
+              <a:ext uri="{FF2B5EF4-FFF2-40B4-BE49-F238E27FC236}">
+                <a16:creationId xmlns:a16="http://schemas.microsoft.com/office/drawing/2014/main" id="{E48A637E-A23A-F19C-2EC6-9A9B52F8A2BA}"/>
+              </a:ext>
+            </a:extLst>
+          </p:cNvPr>
+          <p:cNvSpPr>
+            <a:spLocks noGrp="1"/>
+          </p:cNvSpPr>
+          <p:nvPr>
+            <p:ph idx="1"/>
+          </p:nvPr>
+        </p:nvSpPr>
+        <p:spPr/>
+        <p:txBody>
+          <a:bodyPr/>
+          <a:lstStyle/>
+          <a:p>
+            <a:r>
+              <a:rPr lang="en-US" dirty="0"/>
+              <a:t>Where do we </a:t>
+            </a:r>
+            <a:r>
+              <a:rPr lang="en-US"/>
+              <a:t>go from there?</a:t>
+            </a:r>
+          </a:p>
+        </p:txBody>
+      </p:sp>
+    </p:spTree>
+    <p:extLst>
+      <p:ext uri="{BB962C8B-B14F-4D97-AF65-F5344CB8AC3E}">
+        <p14:creationId xmlns:p14="http://schemas.microsoft.com/office/powerpoint/2010/main" val="1238321945"/>
       </p:ext>
     </p:extLst>
   </p:cSld>

</xml_diff>